<commit_message>
Final submission details: team on title slide, clone steps, signed disclosure
- Title slide and README list the team without placeholder rows
- README quick start starts from git clone + checkout of the judged tag
- Deck checklist points to the demo video in the tagged commit
- AI disclosure form carries the representative's typed signature

Co-Authored-By: Claude Opus 5.5 <noreply@anthropic.com>
Claude-Session: https://claude.ai/code/session_01Ejc5zyhndz5TfQyGisVnYz
</commit_message>
<xml_diff>
--- a/presentation/VITV_Kairos_Submission.pptx
+++ b/presentation/VITV_Kairos_Submission.pptx
@@ -13290,93 +13290,6 @@
                 <a:cs typeface="Calibri"/>
                 <a:sym typeface="Calibri"/>
               </a:rPr>
-              <a:t>Member Name &amp; Email 2- [name, email]</a:t>
-            </a:r>
-            <a:endParaRPr/>
-          </a:p>
-          <a:p>
-            <a:pPr indent="-177800" lvl="0" marL="177800" marR="0" rtl="0" algn="l">
-              <a:spcBef>
-                <a:spcPts val="0"/>
-              </a:spcBef>
-              <a:spcAft>
-                <a:spcPts val="0"/>
-              </a:spcAft>
-              <a:buClr>
-                <a:srgbClr val="63637E"/>
-              </a:buClr>
-              <a:buSzPts val="1600"/>
-              <a:buFont typeface="Calibri"/>
-              <a:buChar char="•"/>
-            </a:pPr>
-            <a:r>
-              <a:rPr b="0" i="0" lang="en-US" sz="1600" u="none" cap="none" strike="noStrike">
-                <a:solidFill>
-                  <a:srgbClr val="63637E"/>
-                </a:solidFill>
-                <a:latin typeface="Calibri"/>
-                <a:ea typeface="Calibri"/>
-                <a:cs typeface="Calibri"/>
-                <a:sym typeface="Calibri"/>
-              </a:rPr>
-              <a:t>Member Name &amp; Email 3- [name, email]</a:t>
-            </a:r>
-            <a:endParaRPr/>
-          </a:p>
-          <a:p>
-            <a:pPr indent="-177800" lvl="0" marL="177800" marR="0" rtl="0" algn="l">
-              <a:spcBef>
-                <a:spcPts val="0"/>
-              </a:spcBef>
-              <a:spcAft>
-                <a:spcPts val="0"/>
-              </a:spcAft>
-              <a:buClr>
-                <a:srgbClr val="63637E"/>
-              </a:buClr>
-              <a:buSzPts val="1600"/>
-              <a:buFont typeface="Calibri"/>
-              <a:buChar char="•"/>
-            </a:pPr>
-            <a:r>
-              <a:rPr b="0" i="0" lang="en-US" sz="1600" u="none" cap="none" strike="noStrike">
-                <a:solidFill>
-                  <a:srgbClr val="63637E"/>
-                </a:solidFill>
-                <a:latin typeface="Calibri"/>
-                <a:ea typeface="Calibri"/>
-                <a:cs typeface="Calibri"/>
-                <a:sym typeface="Calibri"/>
-              </a:rPr>
-              <a:t>Member Name &amp; Email 4- [name, email]</a:t>
-            </a:r>
-            <a:endParaRPr/>
-          </a:p>
-          <a:p>
-            <a:pPr indent="-177800" lvl="0" marL="177800" marR="0" rtl="0" algn="l">
-              <a:spcBef>
-                <a:spcPts val="0"/>
-              </a:spcBef>
-              <a:spcAft>
-                <a:spcPts val="0"/>
-              </a:spcAft>
-              <a:buClr>
-                <a:srgbClr val="63637E"/>
-              </a:buClr>
-              <a:buSzPts val="1600"/>
-              <a:buFont typeface="Calibri"/>
-              <a:buChar char="•"/>
-            </a:pPr>
-            <a:r>
-              <a:rPr b="0" i="0" lang="en-US" sz="1600" u="none" cap="none" strike="noStrike">
-                <a:solidFill>
-                  <a:srgbClr val="63637E"/>
-                </a:solidFill>
-                <a:latin typeface="Calibri"/>
-                <a:ea typeface="Calibri"/>
-                <a:cs typeface="Calibri"/>
-                <a:sym typeface="Calibri"/>
-              </a:rPr>
               <a:t>Submission Github link - github.com/CodeThread386/kairos-streaming-rag (tag PRISM_GENAI_HACKATHON_Y2026)</a:t>
             </a:r>
             <a:endParaRPr/>
@@ -14323,7 +14236,7 @@
                 <a:cs typeface="Calibri"/>
                 <a:sym typeface="Calibri"/>
               </a:rPr>
-              <a:t>Demo video, max 5 minutes: Y (demo/kairos_demo.mp4 in the repo; YouTube link in README)</a:t>
+              <a:t>Demo video, max 5 minutes: Y (demo/kairos_demo.mp4, 3 min 30 s, in the tagged commit)</a:t>
             </a:r>
             <a:endParaRPr sz="2800"/>
           </a:p>

</xml_diff>

<commit_message>
Add team members Gurutheja Kavuturi and Nigam Kundu to deck and README
Co-Authored-By: Claude Opus 5.5 <noreply@anthropic.com>
Claude-Session: https://claude.ai/code/session_01Ejc5zyhndz5TfQyGisVnYz
</commit_message>
<xml_diff>
--- a/presentation/VITV_Kairos_Submission.pptx
+++ b/presentation/VITV_Kairos_Submission.pptx
@@ -13262,6 +13262,64 @@
                 <a:sym typeface="Calibri"/>
               </a:rPr>
               <a:t>Member Name &amp; Email 1- Sarthak Trivedi, sarthak.trivedi2024@vitstudent.ac.in</a:t>
+            </a:r>
+            <a:endParaRPr/>
+          </a:p>
+          <a:p>
+            <a:pPr indent="-177800" lvl="0" marL="177800" marR="0" rtl="0" algn="l">
+              <a:spcBef>
+                <a:spcPts val="0"/>
+              </a:spcBef>
+              <a:spcAft>
+                <a:spcPts val="0"/>
+              </a:spcAft>
+              <a:buClr>
+                <a:srgbClr val="63637E"/>
+              </a:buClr>
+              <a:buSzPts val="1600"/>
+              <a:buFont typeface="Calibri"/>
+              <a:buChar char="•"/>
+            </a:pPr>
+            <a:r>
+              <a:rPr b="0" i="0" lang="en-US" sz="1600" u="none" cap="none" strike="noStrike">
+                <a:solidFill>
+                  <a:srgbClr val="63637E"/>
+                </a:solidFill>
+                <a:latin typeface="Calibri"/>
+                <a:ea typeface="Calibri"/>
+                <a:cs typeface="Calibri"/>
+                <a:sym typeface="Calibri"/>
+              </a:rPr>
+              <a:t>Member Name 2- Gurutheja Kavuturi</a:t>
+            </a:r>
+            <a:endParaRPr/>
+          </a:p>
+          <a:p>
+            <a:pPr indent="-177800" lvl="0" marL="177800" marR="0" rtl="0" algn="l">
+              <a:spcBef>
+                <a:spcPts val="0"/>
+              </a:spcBef>
+              <a:spcAft>
+                <a:spcPts val="0"/>
+              </a:spcAft>
+              <a:buClr>
+                <a:srgbClr val="63637E"/>
+              </a:buClr>
+              <a:buSzPts val="1600"/>
+              <a:buFont typeface="Calibri"/>
+              <a:buChar char="•"/>
+            </a:pPr>
+            <a:r>
+              <a:rPr b="0" i="0" lang="en-US" sz="1600" u="none" cap="none" strike="noStrike">
+                <a:solidFill>
+                  <a:srgbClr val="63637E"/>
+                </a:solidFill>
+                <a:latin typeface="Calibri"/>
+                <a:ea typeface="Calibri"/>
+                <a:cs typeface="Calibri"/>
+                <a:sym typeface="Calibri"/>
+              </a:rPr>
+              <a:t>Member Name 3- Nigam Kundu</a:t>
             </a:r>
             <a:endParaRPr/>
           </a:p>

</xml_diff>